<commit_message>
Real-data self-calibration on MetroPT-3; keep only the pictorial deck
- metropt_selfcal.py: add the duty-cycle test. On 1.5 M real MetroPT-3
  readings every documented-leak night ran the compressor loaded all night;
  all four rank in the top 7 of 159 depot nights (AUC 0.988 vs 0.58 for the
  synthetic anomaly model). Frozen-signal nights excluded by the
  sensor-health rule; caveats recorded in the report.
- reports/metropt3_selfcal.json: nightly summary results (no raw data)
- Evidence screen shows the real-data result (English + Tamil)
- Deck: slides 11, 14 and 15 updated with the real-data result;
  removed the older text-heavy deck
- 125 tests pass

Co-Authored-By: Claude Opus 5.5 <noreply@anthropic.com>
</commit_message>
<xml_diff>
--- a/submission/FactoryAirTwin_Vishwakarma_Stage2.pptx
+++ b/submission/FactoryAirTwin_Vishwakarma_Stage2.pptx
@@ -122,62 +122,62 @@
   <p:extLst>
     <p:ext uri="{521415D9-36F7-43E2-AB2F-B90AF26B5E84}">
       <p14:sectionLst xmlns:p14="http://schemas.microsoft.com/office/powerpoint/2010/main">
-        <p14:section name="Application ID" id="{b6a27cd5-3567-707d-ef4b-6db81bf728a3}">
+        <p14:section name="Application ID" id="{99202f8b-74d5-dc6b-2678-b00341df7dd6}">
           <p14:sldIdLst>
             <p14:sldId id="256"/>
           </p14:sldIdLst>
         </p14:section>
-        <p14:section name="Problem context" id="{cdab35cf-e69e-ef81-7fb4-f02478f621f1}">
+        <p14:section name="Problem context" id="{90bb3786-8e37-de85-5f16-5e531ada4ce3}">
           <p14:sldIdLst>
             <p14:sldId id="257"/>
             <p14:sldId id="258"/>
           </p14:sldIdLst>
         </p14:section>
-        <p14:section name="User journey" id="{8bf601f4-5642-a509-2849-b29b40180dc0}">
+        <p14:section name="User journey" id="{e340035d-c1c9-e2ac-8f43-052622848698}">
           <p14:sldIdLst>
             <p14:sldId id="259"/>
             <p14:sldId id="260"/>
           </p14:sldIdLst>
         </p14:section>
-        <p14:section name="System architecture" id="{daafa399-7339-e7e0-df5d-1b4414ab4f59}">
+        <p14:section name="System architecture" id="{ddc5a473-dc6f-045f-fe7c-1cea697a5f29}">
           <p14:sldIdLst>
             <p14:sldId id="261"/>
             <p14:sldId id="262"/>
           </p14:sldIdLst>
         </p14:section>
-        <p14:section name="CAD &amp; mechanical" id="{cdf4b74e-f43b-a0de-5979-abe2d2f81a7d}">
+        <p14:section name="CAD &amp; mechanical" id="{65b7e918-915a-2176-a6d8-c4e03cb15a96}">
           <p14:sldIdLst>
             <p14:sldId id="263"/>
           </p14:sldIdLst>
         </p14:section>
-        <p14:section name="Electronics &amp; BOM" id="{63ce406b-5bb3-cf12-ac61-af89f6e5cb69}">
+        <p14:section name="Electronics &amp; BOM" id="{8442c8ea-2aa6-a987-571a-47b18e9e1c4b}">
           <p14:sldIdLst>
             <p14:sldId id="264"/>
           </p14:sldIdLst>
         </p14:section>
-        <p14:section name="Maker journey" id="{936b4c28-e588-ac17-da03-bc8181e3d6f4}">
+        <p14:section name="Maker journey" id="{9b01c999-1bd6-0b5f-d057-28cfde847d3d}">
           <p14:sldIdLst>
             <p14:sldId id="265"/>
             <p14:sldId id="266"/>
           </p14:sldIdLst>
         </p14:section>
-        <p14:section name="Safety &amp; hazard mitigation" id="{65d88784-b89d-6e34-494c-84560bbe79c4}">
+        <p14:section name="Safety &amp; hazard mitigation" id="{07ac9689-da89-00a6-c08a-0c9d675a3798}">
           <p14:sldIdLst>
             <p14:sldId id="267"/>
           </p14:sldIdLst>
         </p14:section>
-        <p14:section name="Roadmap" id="{21c132be-de97-5b7a-5093-17d30a5080c6}">
+        <p14:section name="Roadmap" id="{bfd5206a-8d93-adff-03c1-4a1b2be5471f}">
           <p14:sldIdLst>
             <p14:sldId id="268"/>
           </p14:sldIdLst>
         </p14:section>
-        <p14:section name="Technical challenges &amp; risks" id="{9c91c7aa-d3e7-c5c8-23e0-1aa7f506fdcc}">
+        <p14:section name="Technical challenges &amp; risks" id="{cb054cb8-9446-b8b9-ba69-b15dcd8c49f9}">
           <p14:sldIdLst>
             <p14:sldId id="269"/>
             <p14:sldId id="270"/>
           </p14:sldIdLst>
         </p14:section>
-        <p14:section name="References" id="{b7d78a30-f1d8-540d-5eb6-c69a7cb08a0c}">
+        <p14:section name="References" id="{66ae2312-a197-f653-e372-5663f5603ee9}">
           <p14:sldIdLst>
             <p14:sldId id="271"/>
           </p14:sldIdLst>
@@ -5852,7 +5852,7 @@
                 <a:ea typeface="Bahnschrift" pitchFamily="34" charset="-122"/>
                 <a:cs typeface="Bahnschrift" pitchFamily="34" charset="-120"/>
               </a:rPr>
-              <a:t>Real data humbled the AI</a:t>
+              <a:t>Real data: AI failed, physics worked</a:t>
             </a:r>
             <a:endParaRPr lang="en-US" sz="1600" dirty="0"/>
           </a:p>
@@ -5891,7 +5891,7 @@
                 <a:ea typeface="Calibri" pitchFamily="34" charset="-122"/>
                 <a:cs typeface="Calibri" pitchFamily="34" charset="-120"/>
               </a:rPr>
-              <a:t>MetroPT-3: synthetic threshold flagged 0 real windows (AUC 0.58) → money now comes from a physics test that learns each plant</a:t>
+              <a:t>MetroPT-3 (real): the synthetic AI flagged 0 windows (AUC 0.58); the physics duty test put all 4 documented-leak nights in the top 7 of 159 (AUC 0.988)</a:t>
             </a:r>
             <a:endParaRPr lang="en-US" sz="1250" dirty="0"/>
           </a:p>
@@ -10413,7 +10413,7 @@
                 <a:ea typeface="Calibri" pitchFamily="34" charset="-122"/>
                 <a:cs typeface="Calibri" pitchFamily="34" charset="-120"/>
               </a:rPr>
-              <a:t>MetroPT-3: 0 windows flagged, AUC 0.58.</a:t>
+              <a:t>MetroPT-3: 0 windows flagged, AUC 0.58. The physics test scored 0.988.</a:t>
             </a:r>
             <a:endParaRPr lang="en-US" sz="1300" dirty="0"/>
           </a:p>
@@ -11816,7 +11816,7 @@
                 <a:ea typeface="Calibri" pitchFamily="34" charset="-122"/>
                 <a:cs typeface="Calibri" pitchFamily="34" charset="-120"/>
               </a:rPr>
-              <a:t>Physics self-calibration sets all ₹; ML only ranks</a:t>
+              <a:t>Physics sets all ₹: AUC 0.988 on real MetroPT-3 nights</a:t>
             </a:r>
             <a:endParaRPr lang="en-US" sz="1250" dirty="0"/>
           </a:p>

</xml_diff>

<commit_message>
Final Stage 2 deck: team photos, mentor sign-off, Times New Roman, text fixes
- Slide 10: two team photos (ID badges; review with faculty mentor), 125 tests
- Slide 11: mentor name Dr Sathiyamoorthy R M
- Slide 16: image attribution covers the generated diagrams and concept CAD

Co-Authored-By: Claude Opus 5.5 <noreply@anthropic.com>
</commit_message>
<xml_diff>
--- a/submission/FactoryAirTwin_Vishwakarma_Stage2.pptx
+++ b/submission/FactoryAirTwin_Vishwakarma_Stage2.pptx
@@ -4576,6 +4576,10 @@
             <a:prstDash val="solid"/>
           </a:ln>
         </p:spPr>
+        <p:txBody>
+          <a:bodyPr/>
+          <a:p/>
+        </p:txBody>
       </p:sp>
       <p:pic>
         <p:nvPicPr>
@@ -4622,6 +4626,10 @@
             <a:prstDash val="solid"/>
           </a:ln>
         </p:spPr>
+        <p:txBody>
+          <a:bodyPr/>
+          <a:p/>
+        </p:txBody>
       </p:sp>
       <p:sp>
         <p:nvSpPr>
@@ -4733,6 +4741,10 @@
             <a:prstDash val="solid"/>
           </a:ln>
         </p:spPr>
+        <p:txBody>
+          <a:bodyPr/>
+          <a:p/>
+        </p:txBody>
       </p:sp>
       <p:sp>
         <p:nvSpPr>
@@ -4758,6 +4770,10 @@
             <a:prstDash val="solid"/>
           </a:ln>
         </p:spPr>
+        <p:txBody>
+          <a:bodyPr/>
+          <a:p/>
+        </p:txBody>
       </p:sp>
       <p:pic>
         <p:nvPicPr>
@@ -4913,6 +4929,10 @@
             <a:prstDash val="solid"/>
           </a:ln>
         </p:spPr>
+        <p:txBody>
+          <a:bodyPr/>
+          <a:p/>
+        </p:txBody>
       </p:sp>
       <p:sp>
         <p:nvSpPr>
@@ -4938,6 +4958,10 @@
             <a:prstDash val="solid"/>
           </a:ln>
         </p:spPr>
+        <p:txBody>
+          <a:bodyPr/>
+          <a:p/>
+        </p:txBody>
       </p:sp>
       <p:pic>
         <p:nvPicPr>
@@ -4996,7 +5020,7 @@
                 <a:ea typeface="Bahnschrift" pitchFamily="34" charset="-122"/>
                 <a:cs typeface="Times New Roman" panose="02020603050405020304" pitchFamily="18" charset="0"/>
               </a:rPr>
-              <a:t>124 tests</a:t>
+              <a:t>125 tests</a:t>
             </a:r>
             <a:endParaRPr lang="en-US" sz="1600" dirty="0">
               <a:latin typeface="Times New Roman" panose="02020603050405020304" pitchFamily="18" charset="0"/>
@@ -5073,6 +5097,10 @@
             <a:prstDash val="solid"/>
           </a:ln>
         </p:spPr>
+        <p:txBody>
+          <a:bodyPr/>
+          <a:p/>
+        </p:txBody>
       </p:sp>
       <p:sp>
         <p:nvSpPr>
@@ -5098,6 +5126,10 @@
             <a:prstDash val="solid"/>
           </a:ln>
         </p:spPr>
+        <p:txBody>
+          <a:bodyPr/>
+          <a:p/>
+        </p:txBody>
       </p:sp>
       <p:pic>
         <p:nvPicPr>
@@ -5233,6 +5265,10 @@
             <a:prstDash val="solid"/>
           </a:ln>
         </p:spPr>
+        <p:txBody>
+          <a:bodyPr/>
+          <a:p/>
+        </p:txBody>
       </p:sp>
       <p:sp>
         <p:nvSpPr>
@@ -5258,6 +5294,10 @@
             <a:prstDash val="solid"/>
           </a:ln>
         </p:spPr>
+        <p:txBody>
+          <a:bodyPr/>
+          <a:p/>
+        </p:txBody>
       </p:sp>
       <p:pic>
         <p:nvPicPr>
@@ -5421,36 +5461,6 @@
           </a:p>
         </p:txBody>
       </p:sp>
-      <p:pic>
-        <p:nvPicPr>
-          <p:cNvPr id="40" name="Picture 39">
-            <a:extLst>
-              <a:ext uri="{FF2B5EF4-FFF2-40B4-BE49-F238E27FC236}">
-                <a16:creationId xmlns:a16="http://schemas.microsoft.com/office/drawing/2014/main" id="{FAE3368F-FB6E-055E-01EF-16BA4F05F437}"/>
-              </a:ext>
-            </a:extLst>
-          </p:cNvPr>
-          <p:cNvPicPr>
-            <a:picLocks noChangeAspect="1"/>
-          </p:cNvPicPr>
-          <p:nvPr/>
-        </p:nvPicPr>
-        <p:blipFill>
-          <a:blip r:embed="rId9"/>
-          <a:stretch>
-            <a:fillRect/>
-          </a:stretch>
-        </p:blipFill>
-        <p:spPr>
-          <a:xfrm>
-            <a:off x="9512077" y="905872"/>
-            <a:ext cx="1275525" cy="2824880"/>
-          </a:xfrm>
-          <a:prstGeom prst="rect">
-            <a:avLst/>
-          </a:prstGeom>
-        </p:spPr>
-      </p:pic>
       <p:sp>
         <p:nvSpPr>
           <p:cNvPr id="41" name="TextBox 40">
@@ -5465,8 +5475,8 @@
         </p:nvSpPr>
         <p:spPr>
           <a:xfrm>
-            <a:off x="8686800" y="3699748"/>
-            <a:ext cx="3269421" cy="369332"/>
+            <a:off x="8549640" y="3694176"/>
+            <a:ext cx="3063240" cy="274320"/>
           </a:xfrm>
           <a:prstGeom prst="rect">
             <a:avLst/>
@@ -5474,13 +5484,13 @@
           <a:noFill/>
         </p:spPr>
         <p:txBody>
-          <a:bodyPr wrap="none" rtlCol="0">
+          <a:bodyPr wrap="square" rtlCol="0">
             <a:spAutoFit/>
           </a:bodyPr>
           <a:lstStyle/>
           <a:p>
             <a:r>
-              <a:rPr lang="en-US" dirty="0">
+              <a:rPr lang="en-US" dirty="0" sz="1400">
                 <a:solidFill>
                   <a:srgbClr val="5A6A6F"/>
                 </a:solidFill>
@@ -5499,6 +5509,66 @@
           </a:p>
         </p:txBody>
       </p:sp>
+      <p:pic>
+        <p:nvPicPr>
+          <p:cNvPr id="42" name="Picture 41" descr="3.jpg"/>
+          <p:cNvPicPr>
+            <a:picLocks noChangeAspect="1"/>
+          </p:cNvPicPr>
+          <p:nvPr/>
+        </p:nvPicPr>
+        <p:blipFill>
+          <a:blip r:embed="rId10"/>
+          <a:srcRect t="4836" b="14509"/>
+          <a:stretch>
+            <a:fillRect/>
+          </a:stretch>
+        </p:blipFill>
+        <p:spPr>
+          <a:xfrm>
+            <a:off x="8549640" y="1280160"/>
+            <a:ext cx="3063240" cy="1115568"/>
+          </a:xfrm>
+          <a:prstGeom prst="rect">
+            <a:avLst/>
+          </a:prstGeom>
+          <a:ln>
+            <a:solidFill>
+              <a:srgbClr val="D9DEE0"/>
+            </a:solidFill>
+          </a:ln>
+        </p:spPr>
+      </p:pic>
+      <p:pic>
+        <p:nvPicPr>
+          <p:cNvPr id="43" name="Picture 42" descr="4.jpg"/>
+          <p:cNvPicPr>
+            <a:picLocks noChangeAspect="1"/>
+          </p:cNvPicPr>
+          <p:nvPr/>
+        </p:nvPicPr>
+        <p:blipFill>
+          <a:blip r:embed="rId11"/>
+          <a:srcRect t="14509" b="4836"/>
+          <a:stretch>
+            <a:fillRect/>
+          </a:stretch>
+        </p:blipFill>
+        <p:spPr>
+          <a:xfrm>
+            <a:off x="8549640" y="2487168"/>
+            <a:ext cx="3063240" cy="1115568"/>
+          </a:xfrm>
+          <a:prstGeom prst="rect">
+            <a:avLst/>
+          </a:prstGeom>
+          <a:ln>
+            <a:solidFill>
+              <a:srgbClr val="D9DEE0"/>
+            </a:solidFill>
+          </a:ln>
+        </p:spPr>
+      </p:pic>
     </p:spTree>
   </p:cSld>
   <p:clrMapOvr>
@@ -5638,6 +5708,10 @@
             <a:prstDash val="solid"/>
           </a:ln>
         </p:spPr>
+        <p:txBody>
+          <a:bodyPr/>
+          <a:p/>
+        </p:txBody>
       </p:sp>
       <p:pic>
         <p:nvPicPr>
@@ -5771,6 +5845,10 @@
             <a:prstDash val="solid"/>
           </a:ln>
         </p:spPr>
+        <p:txBody>
+          <a:bodyPr/>
+          <a:p/>
+        </p:txBody>
       </p:sp>
       <p:pic>
         <p:nvPicPr>
@@ -5904,6 +5982,10 @@
             <a:prstDash val="solid"/>
           </a:ln>
         </p:spPr>
+        <p:txBody>
+          <a:bodyPr/>
+          <a:p/>
+        </p:txBody>
       </p:sp>
       <p:pic>
         <p:nvPicPr>
@@ -6037,6 +6119,10 @@
             <a:prstDash val="solid"/>
           </a:ln>
         </p:spPr>
+        <p:txBody>
+          <a:bodyPr/>
+          <a:p/>
+        </p:txBody>
       </p:sp>
       <p:pic>
         <p:nvPicPr>
@@ -6296,6 +6382,10 @@
             <a:prstDash val="dash"/>
           </a:ln>
         </p:spPr>
+        <p:txBody>
+          <a:bodyPr/>
+          <a:p/>
+        </p:txBody>
       </p:sp>
       <p:pic>
         <p:nvPicPr>
@@ -6363,7 +6453,7 @@
                 <a:latin typeface="Times New Roman" panose="02020603050405020304" pitchFamily="18" charset="0"/>
                 <a:cs typeface="Times New Roman" panose="02020603050405020304" pitchFamily="18" charset="0"/>
               </a:rPr>
-              <a:t>R M Sathiyamoorthy</a:t>
+              <a:t>Dr Sathiyamoorthy R M</a:t>
             </a:r>
           </a:p>
           <a:p>
@@ -13034,7 +13124,7 @@
                 <a:ea typeface="Calibri" pitchFamily="34" charset="-122"/>
                 <a:cs typeface="Times New Roman" panose="02020603050405020304" pitchFamily="18" charset="0"/>
               </a:rPr>
-              <a:t>Images: screenshots of the team's own software; diagrams drawn by the team; icons from the open-source Tabler Icons set (MIT licence).</a:t>
+              <a:t>Images: screenshots of the team's own software; diagrams and the concept CAD model generated for this project; icons from the open-source Tabler Icons set (MIT licence).</a:t>
             </a:r>
             <a:endParaRPr lang="en-US" sz="1400" dirty="0">
               <a:latin typeface="Times New Roman" panose="02020603050405020304" pitchFamily="18" charset="0"/>

</xml_diff>